<commit_message>
firxed condition for and-or search with belief states.
</commit_message>
<xml_diff>
--- a/slides/discussion/04_search_with_uncertainty_discussion.pptx
+++ b/slides/discussion/04_search_with_uncertainty_discussion.pptx
@@ -1974,10 +1974,7 @@
               </a:br>
               <a14:m>
                 <m:oMathPara xmlns:m="http://schemas.openxmlformats.org/officeDocument/2006/math">
-                  <m:oMathParaPr>
-                    <m:jc m:val="centerGroup"/>
-                  </m:oMathParaPr>
-                  <m:oMath xmlns:m="http://schemas.openxmlformats.org/officeDocument/2006/math">
+                  <m:oMath>
                     <m:r>
                       <a:rPr lang="en-US" sz="1600" b="0" i="1" smtClean="0">
                         <a:latin typeface="Cambria Math" panose="02040503050406030204" pitchFamily="18" charset="0"/>
@@ -2022,7 +2019,7 @@
                     <m:sSup>
                       <m:sSupPr>
                         <m:ctrlPr>
-                          <a:rPr lang="en-US" sz="1600" b="0" i="1" smtClean="0">
+                          <a:rPr lang="en-US" sz="1600" i="1" smtClean="0">
                             <a:latin typeface="Cambria Math" panose="02040503050406030204" pitchFamily="18" charset="0"/>
                           </a:rPr>
                         </m:ctrlPr>
@@ -3060,7 +3057,7 @@
               <m:sSup>
                 <m:sSupPr>
                   <m:ctrlPr>
-                    <a:rPr lang="en-US" sz="1600" b="0" i="1" kern="1200" smtClean="0">
+                    <a:rPr lang="en-US" sz="1600" i="1" kern="1200" smtClean="0">
                       <a:latin typeface="Cambria Math" panose="02040503050406030204" pitchFamily="18" charset="0"/>
                     </a:rPr>
                   </m:ctrlPr>
@@ -6134,7 +6131,7 @@
             <a:fld id="{46E2045A-045A-4BC7-A4D3-1395440B1C3D}" type="datetimeFigureOut">
               <a:rPr lang="en-US" smtClean="0"/>
               <a:pPr/>
-              <a:t>3/5/2026</a:t>
+              <a:t>10/9/2026</a:t>
             </a:fld>
             <a:endParaRPr lang="en-US"/>
           </a:p>
@@ -10899,14 +10896,11 @@
                 <a:pPr/>
                 <a14:m>
                   <m:oMathPara xmlns:m="http://schemas.openxmlformats.org/officeDocument/2006/math">
-                    <m:oMathParaPr>
-                      <m:jc m:val="centerGroup"/>
-                    </m:oMathParaPr>
-                    <m:oMath xmlns:m="http://schemas.openxmlformats.org/officeDocument/2006/math">
+                    <m:oMath>
                       <m:sSub>
                         <m:sSubPr>
                           <m:ctrlPr>
-                            <a:rPr lang="en-US" sz="1600" i="1" smtClean="0">
+                            <a:rPr lang="en-US" sz="1600" i="1">
                               <a:latin typeface="Cambria Math" panose="02040503050406030204" pitchFamily="18" charset="0"/>
                               <a:ea typeface="Cambria Math" panose="02040503050406030204" pitchFamily="18" charset="0"/>
                             </a:rPr>
@@ -13040,7 +13034,7 @@
                     <m:d>
                       <m:dPr>
                         <m:ctrlPr>
-                          <a:rPr lang="en-US" i="1" dirty="0">
+                          <a:rPr lang="en-US" b="0" i="1" dirty="0">
                             <a:latin typeface="Cambria Math" panose="02040503050406030204" pitchFamily="18" charset="0"/>
                           </a:rPr>
                         </m:ctrlPr>
@@ -13445,10 +13439,7 @@
                 <a:pPr algn="ctr"/>
                 <a14:m>
                   <m:oMathPara xmlns:m="http://schemas.openxmlformats.org/officeDocument/2006/math">
-                    <m:oMathParaPr>
-                      <m:jc m:val="centerGroup"/>
-                    </m:oMathParaPr>
-                    <m:oMath xmlns:m="http://schemas.openxmlformats.org/officeDocument/2006/math">
+                    <m:oMath>
                       <m:r>
                         <a:rPr lang="en-US" i="1" dirty="0" smtClean="0">
                           <a:latin typeface="Cambria Math" panose="02040503050406030204" pitchFamily="18" charset="0"/>
@@ -13682,7 +13673,7 @@
         <p:spPr>
           <a:xfrm>
             <a:off x="1295400" y="5334000"/>
-            <a:ext cx="5853205" cy="461665"/>
+            <a:ext cx="6586227" cy="461665"/>
           </a:xfrm>
           <a:prstGeom prst="rect">
             <a:avLst/>
@@ -13725,7 +13716,7 @@
                   <a:srgbClr val="FF0000"/>
                 </a:solidFill>
               </a:rPr>
-              <a:t> b = {6} </a:t>
+              <a:t> o = [B, Dirty] </a:t>
             </a:r>
             <a:r>
               <a:rPr lang="en-US" sz="2400" b="1" dirty="0">
@@ -13780,8 +13771,8 @@
         </p:nvSpPr>
         <p:spPr>
           <a:xfrm>
-            <a:off x="4812159" y="6026087"/>
-            <a:ext cx="2607339" cy="731313"/>
+            <a:off x="4857179" y="5998182"/>
+            <a:ext cx="2045841" cy="627434"/>
           </a:xfrm>
           <a:prstGeom prst="wedgeRoundRectCallout">
             <a:avLst>
@@ -13813,16 +13804,8 @@
           <a:p>
             <a:pPr algn="ctr"/>
             <a:r>
-              <a:rPr lang="en-US" i="1" dirty="0"/>
-              <a:t>b = {6} </a:t>
-            </a:r>
-            <a:r>
               <a:rPr lang="en-US" dirty="0"/>
-              <a:t>is the result of the update with </a:t>
-            </a:r>
-            <a:r>
-              <a:rPr lang="en-US" i="1" dirty="0"/>
-              <a:t>o = [B, Dirty]</a:t>
+              <a:t>Conditioned on the observation.</a:t>
             </a:r>
           </a:p>
         </p:txBody>
@@ -22693,13 +22676,13 @@
               <a:avLst/>
             </a:prstGeom>
             <a:blipFill>
-              <a:blip r:embed="rId2">
+              <a:blip>
                 <a:extLst>
                   <a:ext uri="{28A0092B-C50C-407E-A947-70E740481C1C}">
                     <a14:useLocalDpi xmlns:a14="http://schemas.microsoft.com/office/drawing/2010/main" val="0"/>
                   </a:ext>
                   <a:ext uri="{96DAC541-7B7A-43D3-8B79-37D633B846F1}">
-                    <asvg:svgBlip xmlns:asvg="http://schemas.microsoft.com/office/drawing/2016/SVG/main" r:embed="rId3"/>
+                    <asvg:svgBlip xmlns:asvg="http://schemas.microsoft.com/office/drawing/2016/SVG/main" r:embed="rId2"/>
                   </a:ext>
                 </a:extLst>
               </a:blip>
@@ -22990,13 +22973,13 @@
               <a:avLst/>
             </a:prstGeom>
             <a:blipFill>
-              <a:blip r:embed="rId4">
+              <a:blip>
                 <a:extLst>
                   <a:ext uri="{28A0092B-C50C-407E-A947-70E740481C1C}">
                     <a14:useLocalDpi xmlns:a14="http://schemas.microsoft.com/office/drawing/2010/main" val="0"/>
                   </a:ext>
                   <a:ext uri="{96DAC541-7B7A-43D3-8B79-37D633B846F1}">
-                    <asvg:svgBlip xmlns:asvg="http://schemas.microsoft.com/office/drawing/2016/SVG/main" r:embed="rId5"/>
+                    <asvg:svgBlip xmlns:asvg="http://schemas.microsoft.com/office/drawing/2016/SVG/main" r:embed="rId3"/>
                   </a:ext>
                 </a:extLst>
               </a:blip>
@@ -23291,13 +23274,13 @@
               <a:avLst/>
             </a:prstGeom>
             <a:blipFill>
-              <a:blip r:embed="rId6">
+              <a:blip>
                 <a:extLst>
                   <a:ext uri="{28A0092B-C50C-407E-A947-70E740481C1C}">
                     <a14:useLocalDpi xmlns:a14="http://schemas.microsoft.com/office/drawing/2010/main" val="0"/>
                   </a:ext>
                   <a:ext uri="{96DAC541-7B7A-43D3-8B79-37D633B846F1}">
-                    <asvg:svgBlip xmlns:asvg="http://schemas.microsoft.com/office/drawing/2016/SVG/main" r:embed="rId7"/>
+                    <asvg:svgBlip xmlns:asvg="http://schemas.microsoft.com/office/drawing/2016/SVG/main" r:embed="rId4"/>
                   </a:ext>
                 </a:extLst>
               </a:blip>
@@ -23587,13 +23570,13 @@
               <a:avLst/>
             </a:prstGeom>
             <a:blipFill>
-              <a:blip r:embed="rId8">
+              <a:blip>
                 <a:extLst>
                   <a:ext uri="{28A0092B-C50C-407E-A947-70E740481C1C}">
                     <a14:useLocalDpi xmlns:a14="http://schemas.microsoft.com/office/drawing/2010/main" val="0"/>
                   </a:ext>
                   <a:ext uri="{96DAC541-7B7A-43D3-8B79-37D633B846F1}">
-                    <asvg:svgBlip xmlns:asvg="http://schemas.microsoft.com/office/drawing/2016/SVG/main" r:embed="rId9"/>
+                    <asvg:svgBlip xmlns:asvg="http://schemas.microsoft.com/office/drawing/2016/SVG/main" r:embed="rId5"/>
                   </a:ext>
                 </a:extLst>
               </a:blip>

</xml_diff>